<commit_message>
W02/D3: both decks rebuilt so every diagram is drawn at its own width
The first build dropped mmdc's -w through a PATH shim, which drew the WHERE aside (936 CSS pixels)
at 784. The rebuild uses the build_deck.py fix raised in its own pull request; the provenance says
so.

Co-Authored-By: Claude Opus 5.5 <noreply@anthropic.com>
Claude-Session: https://claude.ai/code/session_013SfKy2LmHzQWmAfT6NcxQs
</commit_message>
<xml_diff>
--- a/content/W02/D3/slides/C2_W02_D03_half1_STUDENT.pptx
+++ b/content/W02/D3/slides/C2_W02_D03_half1_STUDENT.pptx
@@ -13157,7 +13157,7 @@
       </p:sp>
       <p:pic>
         <p:nvPicPr>
-          <p:cNvPr id="9" name="mermaid diagram" descr="4a507617d3782b84.png"/>
+          <p:cNvPr id="9" name="mermaid diagram" descr="818e5812c42e9826.png"/>
           <p:cNvPicPr>
             <a:picLocks noChangeAspect="1"/>
           </p:cNvPicPr>
@@ -13964,7 +13964,7 @@
       </p:sp>
       <p:pic>
         <p:nvPicPr>
-          <p:cNvPr id="9" name="mermaid diagram" descr="dfb7f7dcd79bc1ba.png"/>
+          <p:cNvPr id="9" name="mermaid diagram" descr="7ef44a2d0006e263.png"/>
           <p:cNvPicPr>
             <a:picLocks noChangeAspect="1"/>
           </p:cNvPicPr>
@@ -15042,7 +15042,7 @@
       </p:sp>
       <p:pic>
         <p:nvPicPr>
-          <p:cNvPr id="14" name="mermaid diagram" descr="65fd2146f95aaad4.png"/>
+          <p:cNvPr id="14" name="mermaid diagram" descr="06c99e96ab73fe5d.png"/>
           <p:cNvPicPr>
             <a:picLocks noChangeAspect="1"/>
           </p:cNvPicPr>
@@ -15057,7 +15057,7 @@
         <p:spPr>
           <a:xfrm>
             <a:off x="530352" y="2831084"/>
-            <a:ext cx="11130991" cy="1121617"/>
+            <a:ext cx="11130991" cy="1129748"/>
           </a:xfrm>
           <a:prstGeom prst="rect">
             <a:avLst/>
@@ -22452,7 +22452,7 @@
       </p:sp>
       <p:pic>
         <p:nvPicPr>
-          <p:cNvPr id="9" name="mermaid diagram" descr="65c39f22671186db.png"/>
+          <p:cNvPr id="9" name="mermaid diagram" descr="069742a8089cc0d4.png"/>
           <p:cNvPicPr>
             <a:picLocks noChangeAspect="1"/>
           </p:cNvPicPr>
@@ -27597,7 +27597,7 @@
       </p:sp>
       <p:pic>
         <p:nvPicPr>
-          <p:cNvPr id="9" name="mermaid diagram" descr="09a61d9d9a71cf66.png"/>
+          <p:cNvPr id="9" name="mermaid diagram" descr="83b5168f5f4a30a2.png"/>
           <p:cNvPicPr>
             <a:picLocks noChangeAspect="1"/>
           </p:cNvPicPr>
@@ -28350,7 +28350,7 @@
       </p:sp>
       <p:pic>
         <p:nvPicPr>
-          <p:cNvPr id="9" name="mermaid diagram" descr="04ddf3cde7972034.png"/>
+          <p:cNvPr id="9" name="mermaid diagram" descr="f187dfcac7c5c453.png"/>
           <p:cNvPicPr>
             <a:picLocks noChangeAspect="1"/>
           </p:cNvPicPr>
@@ -35863,7 +35863,7 @@
       </p:sp>
       <p:pic>
         <p:nvPicPr>
-          <p:cNvPr id="9" name="mermaid diagram" descr="1519f272a037a520.png"/>
+          <p:cNvPr id="9" name="mermaid diagram" descr="eb7fd92cbec98375.png"/>
           <p:cNvPicPr>
             <a:picLocks noChangeAspect="1"/>
           </p:cNvPicPr>
@@ -40026,7 +40026,7 @@
       </p:sp>
       <p:pic>
         <p:nvPicPr>
-          <p:cNvPr id="9" name="mermaid diagram" descr="efd071a1195badef.png"/>
+          <p:cNvPr id="9" name="mermaid diagram" descr="a260f1bd8b0a8f14.png"/>
           <p:cNvPicPr>
             <a:picLocks noChangeAspect="1"/>
           </p:cNvPicPr>
@@ -40833,7 +40833,7 @@
       </p:sp>
       <p:pic>
         <p:nvPicPr>
-          <p:cNvPr id="9" name="mermaid diagram" descr="ccd9dc72bf2e93c1.png"/>
+          <p:cNvPr id="9" name="mermaid diagram" descr="be6527f2103f3f17.png"/>
           <p:cNvPicPr>
             <a:picLocks noChangeAspect="1"/>
           </p:cNvPicPr>
@@ -44384,7 +44384,7 @@
       </p:sp>
       <p:pic>
         <p:nvPicPr>
-          <p:cNvPr id="10" name="mermaid diagram" descr="0f2dd2aeb89fba87.png"/>
+          <p:cNvPr id="10" name="mermaid diagram" descr="85555365be3c0ceb.png"/>
           <p:cNvPicPr>
             <a:picLocks noChangeAspect="1"/>
           </p:cNvPicPr>
@@ -52005,7 +52005,7 @@
       </p:sp>
       <p:pic>
         <p:nvPicPr>
-          <p:cNvPr id="9" name="mermaid diagram" descr="43249a5ad3541adb.png"/>
+          <p:cNvPr id="9" name="mermaid diagram" descr="2148a1327f2349c8.png"/>
           <p:cNvPicPr>
             <a:picLocks noChangeAspect="1"/>
           </p:cNvPicPr>
@@ -56314,7 +56314,7 @@
       </p:sp>
       <p:pic>
         <p:nvPicPr>
-          <p:cNvPr id="9" name="mermaid diagram" descr="baf6bf1b461432b2.png"/>
+          <p:cNvPr id="9" name="mermaid diagram" descr="a2e9a95e8ae96427.png"/>
           <p:cNvPicPr>
             <a:picLocks noChangeAspect="1"/>
           </p:cNvPicPr>

</xml_diff>

<commit_message>
W02/D3: half1 S37 says eight rows are hidden
Co-Authored-By: Claude Opus 5.5 <noreply@anthropic.com>
Claude-Session: https://claude.ai/code/session_01TqMoycMRvWSVphHv5tXoPT
</commit_message>
<xml_diff>
--- a/content/W02/D3/slides/C2_W02_D03_half1_STUDENT.pptx
+++ b/content/W02/D3/slides/C2_W02_D03_half1_STUDENT.pptx
@@ -20228,7 +20228,7 @@
                 </a:solidFill>
                 <a:latin typeface="Calibri"/>
               </a:rPr>
-              <a:t>Week 2 Wednesday: the protect list</a:t>
+              <a:t>Week 2, Day 3. The protect list, ranked the way it was asked</a:t>
             </a:r>
           </a:p>
         </p:txBody>
@@ -20794,7 +20794,7 @@
                 </a:solidFill>
                 <a:latin typeface="Calibri"/>
               </a:rPr>
-              <a:t>Week 2 Wednesday: the protect list</a:t>
+              <a:t>Week 2, Day 3. The protect list, ranked the way it was asked</a:t>
             </a:r>
           </a:p>
         </p:txBody>
@@ -34331,7 +34331,7 @@
                 </a:solidFill>
                 <a:latin typeface="Calibri"/>
               </a:rPr>
-              <a:t>Week 2 Wednesday: the protect list</a:t>
+              <a:t>Week 2, Day 3. The protect list, ranked the way it was asked</a:t>
             </a:r>
           </a:p>
         </p:txBody>
@@ -46583,7 +46583,7 @@
         </p:nvGraphicFramePr>
         <p:xfrm>
           <a:off x="530352" y="1956816"/>
-          <a:ext cx="11130989" cy="1676400"/>
+          <a:ext cx="11130990" cy="2011680"/>
         </p:xfrm>
         <a:graphic>
           <a:graphicData uri="http://schemas.openxmlformats.org/drawingml/2006/table">
@@ -46592,10 +46592,10 @@
                 <a:tableStyleId>{2D5ABB26-0587-4C30-8999-92F81FD0307C}</a:tableStyleId>
               </a:tblPr>
               <a:tblGrid>
-                <a:gridCol w="1847958"/>
-                <a:gridCol w="2326368"/>
-                <a:gridCol w="2641112"/>
-                <a:gridCol w="4315551"/>
+                <a:gridCol w="1619053"/>
+                <a:gridCol w="2727596"/>
+                <a:gridCol w="3003353"/>
+                <a:gridCol w="3780988"/>
               </a:tblGrid>
               <a:tr h="335280">
                 <a:tc>
@@ -46970,7 +46970,7 @@
                           </a:solidFill>
                           <a:latin typeface="Calibri"/>
                         </a:rPr>
-                        <a:t>KR-00979</a:t>
+                        <a:t>...</a:t>
                       </a:r>
                     </a:p>
                   </a:txBody>
@@ -46992,7 +46992,7 @@
                           </a:solidFill>
                           <a:latin typeface="Calibri"/>
                         </a:rPr>
-                        <a:t>Rs 970</a:t>
+                        <a:t>eight more orders</a:t>
                       </a:r>
                     </a:p>
                   </a:txBody>
@@ -47014,7 +47014,7 @@
                           </a:solidFill>
                           <a:latin typeface="Calibri"/>
                         </a:rPr>
-                        <a:t>Rs 3,76,90,290</a:t>
+                        <a:t>Rs 3,76,90,290 each</a:t>
                       </a:r>
                     </a:p>
                   </a:txBody>
@@ -47036,7 +47036,7 @@
                           </a:solidFill>
                           <a:latin typeface="Calibri"/>
                         </a:rPr>
-                        <a:t>Rs 3,76,90,290</a:t>
+                        <a:t>one step each</a:t>
                       </a:r>
                     </a:p>
                   </a:txBody>
@@ -47047,6 +47047,96 @@
                   </a:tcPr>
                 </a:tc>
               </a:tr>
+              <a:tr h="335280">
+                <a:tc>
+                  <a:txBody>
+                    <a:bodyPr/>
+                    <a:lstStyle/>
+                    <a:p>
+                      <a:r>
+                        <a:rPr sz="1200" b="0" i="0">
+                          <a:solidFill>
+                            <a:srgbClr val="1A1440"/>
+                          </a:solidFill>
+                          <a:latin typeface="Calibri"/>
+                        </a:rPr>
+                        <a:t>KR-00979</a:t>
+                      </a:r>
+                    </a:p>
+                  </a:txBody>
+                  <a:tcPr marL="101600" marR="101600" marT="38100" marB="38100" anchor="ctr">
+                    <a:solidFill>
+                      <a:srgbClr val="FFFFFF"/>
+                    </a:solidFill>
+                  </a:tcPr>
+                </a:tc>
+                <a:tc>
+                  <a:txBody>
+                    <a:bodyPr/>
+                    <a:lstStyle/>
+                    <a:p>
+                      <a:r>
+                        <a:rPr sz="1200" b="0" i="0">
+                          <a:solidFill>
+                            <a:srgbClr val="1A1440"/>
+                          </a:solidFill>
+                          <a:latin typeface="Calibri"/>
+                        </a:rPr>
+                        <a:t>Rs 970</a:t>
+                      </a:r>
+                    </a:p>
+                  </a:txBody>
+                  <a:tcPr marL="101600" marR="101600" marT="38100" marB="38100" anchor="ctr">
+                    <a:solidFill>
+                      <a:srgbClr val="FFFFFF"/>
+                    </a:solidFill>
+                  </a:tcPr>
+                </a:tc>
+                <a:tc>
+                  <a:txBody>
+                    <a:bodyPr/>
+                    <a:lstStyle/>
+                    <a:p>
+                      <a:r>
+                        <a:rPr sz="1200" b="0" i="0">
+                          <a:solidFill>
+                            <a:srgbClr val="1A1440"/>
+                          </a:solidFill>
+                          <a:latin typeface="Calibri"/>
+                        </a:rPr>
+                        <a:t>Rs 3,76,90,290</a:t>
+                      </a:r>
+                    </a:p>
+                  </a:txBody>
+                  <a:tcPr marL="101600" marR="101600" marT="38100" marB="38100" anchor="ctr">
+                    <a:solidFill>
+                      <a:srgbClr val="FFFFFF"/>
+                    </a:solidFill>
+                  </a:tcPr>
+                </a:tc>
+                <a:tc>
+                  <a:txBody>
+                    <a:bodyPr/>
+                    <a:lstStyle/>
+                    <a:p>
+                      <a:r>
+                        <a:rPr sz="1200" b="0" i="0">
+                          <a:solidFill>
+                            <a:srgbClr val="1A1440"/>
+                          </a:solidFill>
+                          <a:latin typeface="Calibri"/>
+                        </a:rPr>
+                        <a:t>Rs 3,76,90,290</a:t>
+                      </a:r>
+                    </a:p>
+                  </a:txBody>
+                  <a:tcPr marL="101600" marR="101600" marT="38100" marB="38100" anchor="ctr">
+                    <a:solidFill>
+                      <a:srgbClr val="FFFFFF"/>
+                    </a:solidFill>
+                  </a:tcPr>
+                </a:tc>
+              </a:tr>
             </a:tbl>
           </a:graphicData>
         </a:graphic>
@@ -47059,7 +47149,7 @@
         </p:nvSpPr>
         <p:spPr>
           <a:xfrm>
-            <a:off x="530352" y="3889248"/>
+            <a:off x="530352" y="4224528"/>
             <a:ext cx="11130991" cy="962152"/>
           </a:xfrm>
           <a:prstGeom prst="roundRect">
@@ -47111,7 +47201,7 @@
         </p:nvSpPr>
         <p:spPr>
           <a:xfrm>
-            <a:off x="713232" y="4017263"/>
+            <a:off x="713232" y="4352544"/>
             <a:ext cx="91440" cy="91440"/>
           </a:xfrm>
           <a:prstGeom prst="ellipse">
@@ -47155,7 +47245,7 @@
         </p:nvSpPr>
         <p:spPr>
           <a:xfrm>
-            <a:off x="868680" y="4017263"/>
+            <a:off x="868680" y="4352544"/>
             <a:ext cx="91440" cy="91440"/>
           </a:xfrm>
           <a:prstGeom prst="ellipse">
@@ -47199,7 +47289,7 @@
         </p:nvSpPr>
         <p:spPr>
           <a:xfrm>
-            <a:off x="1024128" y="4017263"/>
+            <a:off x="1024128" y="4352544"/>
             <a:ext cx="91440" cy="91440"/>
           </a:xfrm>
           <a:prstGeom prst="ellipse">
@@ -47243,7 +47333,7 @@
         </p:nvSpPr>
         <p:spPr>
           <a:xfrm>
-            <a:off x="804671" y="4218432"/>
+            <a:off x="804671" y="4553712"/>
             <a:ext cx="10673791" cy="559816"/>
           </a:xfrm>
           <a:prstGeom prst="rect">
@@ -54752,7 +54842,7 @@
                 </a:solidFill>
                 <a:latin typeface="Calibri"/>
               </a:rPr>
-              <a:t>Week 2 Wednesday: the protect list</a:t>
+              <a:t>Week 2, Day 3. The protect list, ranked the way it was asked</a:t>
             </a:r>
           </a:p>
         </p:txBody>

</xml_diff>

<commit_message>
W02/D3: a running total changes between runs only under a ROWS frame, and the pack now says so
The pack said a running total ordered by date alone would not give the same steps on every run. On
Postgres's default frame the tied rows share the day's closing figure on every run; a row's figure
moves between runs only when the total is written with a ROWS frame, which adds tied rows in an order
the database picks. The Week 2 row names that failure, so the study notes, the notebook's worked note
and interview answer, the SQL comment and the deck's speaker note now say which frame produces it, and
that the same tiebreaker fixes both. Kahoot Q4 asks for one step per order. Notebook 03 is rebuilt and
executed from its builder, and the half-one deck is rebuilt.

Co-Authored-By: Claude Opus 5.5 <noreply@anthropic.com>
Claude-Session: https://claude.ai/code/session_01P7zaoR4dQ5pzBFnsX549JQ
</commit_message>
<xml_diff>
--- a/content/W02/D3/slides/C2_W02_D03_half1_STUDENT.pptx
+++ b/content/W02/D3/slides/C2_W02_D03_half1_STUDENT.pptx
@@ -3581,7 +3581,17 @@
           </a:p>
           <a:p>
             <a:r>
-              <a:t>total. Adding order_id makes each row its own step, and the same step on every run. Say the sixth</a:t>
+              <a:t>total. Adding order_id makes each row its own step. If anyone writes the running total with a ROWS</a:t>
+            </a:r>
+          </a:p>
+          <a:p>
+            <a:r>
+              <a:t>frame, tied rows are added in an order the database picks and a row's figure can change between</a:t>
+            </a:r>
+          </a:p>
+          <a:p>
+            <a:r>
+              <a:t>runs; the same tiebreaker fixes it. Say the sixth</a:t>
             </a:r>
           </a:p>
           <a:p>
@@ -13157,7 +13167,7 @@
       </p:sp>
       <p:pic>
         <p:nvPicPr>
-          <p:cNvPr id="9" name="mermaid diagram" descr="818e5812c42e9826.png"/>
+          <p:cNvPr id="9" name="mermaid diagram" descr="4a507617d3782b84.png"/>
           <p:cNvPicPr>
             <a:picLocks noChangeAspect="1"/>
           </p:cNvPicPr>
@@ -13171,8 +13181,8 @@
         </p:blipFill>
         <p:spPr>
           <a:xfrm>
-            <a:off x="780897" y="1956816"/>
-            <a:ext cx="10629900" cy="1600200"/>
+            <a:off x="530352" y="1956816"/>
+            <a:ext cx="11130991" cy="1118763"/>
           </a:xfrm>
           <a:prstGeom prst="rect">
             <a:avLst/>
@@ -13187,7 +13197,7 @@
         </p:nvSpPr>
         <p:spPr>
           <a:xfrm>
-            <a:off x="530352" y="3703320"/>
+            <a:off x="530352" y="3221883"/>
             <a:ext cx="11130991" cy="1121664"/>
           </a:xfrm>
           <a:prstGeom prst="roundRect">
@@ -13241,7 +13251,7 @@
         </p:nvSpPr>
         <p:spPr>
           <a:xfrm>
-            <a:off x="758952" y="4035552"/>
+            <a:off x="758952" y="3554115"/>
             <a:ext cx="457200" cy="457200"/>
           </a:xfrm>
           <a:prstGeom prst="ellipse">
@@ -13293,7 +13303,7 @@
         </p:blipFill>
         <p:spPr>
           <a:xfrm>
-            <a:off x="868680" y="4145280"/>
+            <a:off x="868680" y="3663843"/>
             <a:ext cx="237744" cy="237744"/>
           </a:xfrm>
           <a:prstGeom prst="rect">
@@ -13309,7 +13319,7 @@
         </p:nvSpPr>
         <p:spPr>
           <a:xfrm>
-            <a:off x="1399031" y="3849624"/>
+            <a:off x="1399031" y="3368187"/>
             <a:ext cx="9987991" cy="160401"/>
           </a:xfrm>
           <a:prstGeom prst="rect">
@@ -13344,7 +13354,7 @@
         </p:nvSpPr>
         <p:spPr>
           <a:xfrm>
-            <a:off x="1399031" y="4069080"/>
+            <a:off x="1399031" y="3587643"/>
             <a:ext cx="9987991" cy="682752"/>
           </a:xfrm>
           <a:prstGeom prst="rect">
@@ -13964,7 +13974,7 @@
       </p:sp>
       <p:pic>
         <p:nvPicPr>
-          <p:cNvPr id="9" name="mermaid diagram" descr="7ef44a2d0006e263.png"/>
+          <p:cNvPr id="9" name="mermaid diagram" descr="dfb7f7dcd79bc1ba.png"/>
           <p:cNvPicPr>
             <a:picLocks noChangeAspect="1"/>
           </p:cNvPicPr>
@@ -13978,8 +13988,8 @@
         </p:blipFill>
         <p:spPr>
           <a:xfrm>
-            <a:off x="780897" y="1956816"/>
-            <a:ext cx="10629900" cy="2828925"/>
+            <a:off x="2588266" y="1956816"/>
+            <a:ext cx="7015162" cy="1514475"/>
           </a:xfrm>
           <a:prstGeom prst="rect">
             <a:avLst/>
@@ -13994,7 +14004,7 @@
         </p:nvSpPr>
         <p:spPr>
           <a:xfrm>
-            <a:off x="530352" y="4932045"/>
+            <a:off x="530352" y="3617595"/>
             <a:ext cx="11130991" cy="962152"/>
           </a:xfrm>
           <a:prstGeom prst="roundRect">
@@ -14046,7 +14056,7 @@
         </p:nvSpPr>
         <p:spPr>
           <a:xfrm>
-            <a:off x="713232" y="5060061"/>
+            <a:off x="713232" y="3745611"/>
             <a:ext cx="91440" cy="91440"/>
           </a:xfrm>
           <a:prstGeom prst="ellipse">
@@ -14090,7 +14100,7 @@
         </p:nvSpPr>
         <p:spPr>
           <a:xfrm>
-            <a:off x="868680" y="5060061"/>
+            <a:off x="868680" y="3745611"/>
             <a:ext cx="91440" cy="91440"/>
           </a:xfrm>
           <a:prstGeom prst="ellipse">
@@ -14134,7 +14144,7 @@
         </p:nvSpPr>
         <p:spPr>
           <a:xfrm>
-            <a:off x="1024128" y="5060061"/>
+            <a:off x="1024128" y="3745611"/>
             <a:ext cx="91440" cy="91440"/>
           </a:xfrm>
           <a:prstGeom prst="ellipse">
@@ -14178,7 +14188,7 @@
         </p:nvSpPr>
         <p:spPr>
           <a:xfrm>
-            <a:off x="804671" y="5261229"/>
+            <a:off x="804671" y="3946779"/>
             <a:ext cx="10673791" cy="559816"/>
           </a:xfrm>
           <a:prstGeom prst="rect">
@@ -15042,7 +15052,7 @@
       </p:sp>
       <p:pic>
         <p:nvPicPr>
-          <p:cNvPr id="14" name="mermaid diagram" descr="06c99e96ab73fe5d.png"/>
+          <p:cNvPr id="14" name="mermaid diagram" descr="65fd2146f95aaad4.png"/>
           <p:cNvPicPr>
             <a:picLocks noChangeAspect="1"/>
           </p:cNvPicPr>
@@ -15056,8 +15066,8 @@
         </p:blipFill>
         <p:spPr>
           <a:xfrm>
-            <a:off x="530352" y="2831084"/>
-            <a:ext cx="11130991" cy="1129748"/>
+            <a:off x="1638147" y="2831084"/>
+            <a:ext cx="8915400" cy="1128712"/>
           </a:xfrm>
           <a:prstGeom prst="rect">
             <a:avLst/>
@@ -22452,7 +22462,7 @@
       </p:sp>
       <p:pic>
         <p:nvPicPr>
-          <p:cNvPr id="9" name="mermaid diagram" descr="069742a8089cc0d4.png"/>
+          <p:cNvPr id="9" name="mermaid diagram" descr="65c39f22671186db.png"/>
           <p:cNvPicPr>
             <a:picLocks noChangeAspect="1"/>
           </p:cNvPicPr>
@@ -22466,8 +22476,8 @@
         </p:blipFill>
         <p:spPr>
           <a:xfrm>
-            <a:off x="2152497" y="1956816"/>
-            <a:ext cx="7886700" cy="2786062"/>
+            <a:off x="3088328" y="1956816"/>
+            <a:ext cx="6015037" cy="2014537"/>
           </a:xfrm>
           <a:prstGeom prst="rect">
             <a:avLst/>
@@ -27597,7 +27607,7 @@
       </p:sp>
       <p:pic>
         <p:nvPicPr>
-          <p:cNvPr id="9" name="mermaid diagram" descr="83b5168f5f4a30a2.png"/>
+          <p:cNvPr id="9" name="mermaid diagram" descr="09a61d9d9a71cf66.png"/>
           <p:cNvPicPr>
             <a:picLocks noChangeAspect="1"/>
           </p:cNvPicPr>
@@ -27611,8 +27621,8 @@
         </p:blipFill>
         <p:spPr>
           <a:xfrm>
-            <a:off x="3524097" y="1937671"/>
-            <a:ext cx="5143500" cy="2786062"/>
+            <a:off x="3081185" y="1956816"/>
+            <a:ext cx="6029325" cy="1800225"/>
           </a:xfrm>
           <a:prstGeom prst="rect">
             <a:avLst/>
@@ -27627,7 +27637,7 @@
         </p:nvSpPr>
         <p:spPr>
           <a:xfrm>
-            <a:off x="530352" y="4870037"/>
+            <a:off x="530352" y="3903345"/>
             <a:ext cx="11130991" cy="1074420"/>
           </a:xfrm>
           <a:prstGeom prst="roundRect">
@@ -27675,7 +27685,7 @@
         </p:nvSpPr>
         <p:spPr>
           <a:xfrm>
-            <a:off x="676656" y="4998053"/>
+            <a:off x="676656" y="4031360"/>
             <a:ext cx="45720" cy="818388"/>
           </a:xfrm>
           <a:prstGeom prst="roundRect">
@@ -27721,7 +27731,7 @@
         </p:nvSpPr>
         <p:spPr>
           <a:xfrm>
-            <a:off x="877824" y="4988909"/>
+            <a:off x="877824" y="4022217"/>
             <a:ext cx="10564063" cy="891540"/>
           </a:xfrm>
           <a:prstGeom prst="rect">
@@ -28350,7 +28360,7 @@
       </p:sp>
       <p:pic>
         <p:nvPicPr>
-          <p:cNvPr id="9" name="mermaid diagram" descr="f187dfcac7c5c453.png"/>
+          <p:cNvPr id="9" name="mermaid diagram" descr="04ddf3cde7972034.png"/>
           <p:cNvPicPr>
             <a:picLocks noChangeAspect="1"/>
           </p:cNvPicPr>
@@ -28364,8 +28374,8 @@
         </p:blipFill>
         <p:spPr>
           <a:xfrm>
-            <a:off x="780897" y="1956816"/>
-            <a:ext cx="10629900" cy="1100137"/>
+            <a:off x="2031053" y="1956816"/>
+            <a:ext cx="8129587" cy="871537"/>
           </a:xfrm>
           <a:prstGeom prst="rect">
             <a:avLst/>
@@ -28380,7 +28390,7 @@
         </p:nvSpPr>
         <p:spPr>
           <a:xfrm>
-            <a:off x="530352" y="3203257"/>
+            <a:off x="530352" y="2974657"/>
             <a:ext cx="11130991" cy="1380744"/>
           </a:xfrm>
           <a:prstGeom prst="roundRect">
@@ -28434,7 +28444,7 @@
         </p:nvSpPr>
         <p:spPr>
           <a:xfrm>
-            <a:off x="758952" y="3665029"/>
+            <a:off x="758952" y="3436429"/>
             <a:ext cx="457200" cy="457200"/>
           </a:xfrm>
           <a:prstGeom prst="ellipse">
@@ -28486,7 +28496,7 @@
         </p:blipFill>
         <p:spPr>
           <a:xfrm>
-            <a:off x="868680" y="3774757"/>
+            <a:off x="868680" y="3546157"/>
             <a:ext cx="237744" cy="237744"/>
           </a:xfrm>
           <a:prstGeom prst="rect">
@@ -28502,7 +28512,7 @@
         </p:nvSpPr>
         <p:spPr>
           <a:xfrm>
-            <a:off x="1399031" y="3349561"/>
+            <a:off x="1399031" y="3120961"/>
             <a:ext cx="9987991" cy="160401"/>
           </a:xfrm>
           <a:prstGeom prst="rect">
@@ -28537,7 +28547,7 @@
         </p:nvSpPr>
         <p:spPr>
           <a:xfrm>
-            <a:off x="1399031" y="3569017"/>
+            <a:off x="1399031" y="3340417"/>
             <a:ext cx="9987991" cy="941832"/>
           </a:xfrm>
           <a:prstGeom prst="rect">
@@ -35863,7 +35873,7 @@
       </p:sp>
       <p:pic>
         <p:nvPicPr>
-          <p:cNvPr id="9" name="mermaid diagram" descr="eb7fd92cbec98375.png"/>
+          <p:cNvPr id="9" name="mermaid diagram" descr="1519f272a037a520.png"/>
           <p:cNvPicPr>
             <a:picLocks noChangeAspect="1"/>
           </p:cNvPicPr>
@@ -35877,8 +35887,8 @@
         </p:blipFill>
         <p:spPr>
           <a:xfrm>
-            <a:off x="780897" y="1956816"/>
-            <a:ext cx="10629900" cy="1600200"/>
+            <a:off x="1423835" y="1956816"/>
+            <a:ext cx="9344025" cy="1128712"/>
           </a:xfrm>
           <a:prstGeom prst="rect">
             <a:avLst/>
@@ -35893,7 +35903,7 @@
         </p:nvSpPr>
         <p:spPr>
           <a:xfrm>
-            <a:off x="530352" y="3703320"/>
+            <a:off x="530352" y="3231832"/>
             <a:ext cx="11130991" cy="772160"/>
           </a:xfrm>
           <a:prstGeom prst="rect">
@@ -40026,7 +40036,7 @@
       </p:sp>
       <p:pic>
         <p:nvPicPr>
-          <p:cNvPr id="9" name="mermaid diagram" descr="a260f1bd8b0a8f14.png"/>
+          <p:cNvPr id="9" name="mermaid diagram" descr="efd071a1195badef.png"/>
           <p:cNvPicPr>
             <a:picLocks noChangeAspect="1"/>
           </p:cNvPicPr>
@@ -40040,8 +40050,8 @@
         </p:blipFill>
         <p:spPr>
           <a:xfrm>
-            <a:off x="780897" y="1956816"/>
-            <a:ext cx="10629900" cy="1600200"/>
+            <a:off x="2702566" y="1956816"/>
+            <a:ext cx="6786562" cy="1371600"/>
           </a:xfrm>
           <a:prstGeom prst="rect">
             <a:avLst/>
@@ -40056,7 +40066,7 @@
         </p:nvSpPr>
         <p:spPr>
           <a:xfrm>
-            <a:off x="530352" y="3703320"/>
+            <a:off x="530352" y="3474720"/>
             <a:ext cx="11130991" cy="1121664"/>
           </a:xfrm>
           <a:prstGeom prst="roundRect">
@@ -40110,7 +40120,7 @@
         </p:nvSpPr>
         <p:spPr>
           <a:xfrm>
-            <a:off x="758952" y="4035552"/>
+            <a:off x="758952" y="3806952"/>
             <a:ext cx="457200" cy="457200"/>
           </a:xfrm>
           <a:prstGeom prst="ellipse">
@@ -40162,7 +40172,7 @@
         </p:blipFill>
         <p:spPr>
           <a:xfrm>
-            <a:off x="868680" y="4145280"/>
+            <a:off x="868680" y="3916680"/>
             <a:ext cx="237744" cy="237744"/>
           </a:xfrm>
           <a:prstGeom prst="rect">
@@ -40178,7 +40188,7 @@
         </p:nvSpPr>
         <p:spPr>
           <a:xfrm>
-            <a:off x="1399031" y="3849624"/>
+            <a:off x="1399031" y="3621024"/>
             <a:ext cx="9987991" cy="160401"/>
           </a:xfrm>
           <a:prstGeom prst="rect">
@@ -40213,7 +40223,7 @@
         </p:nvSpPr>
         <p:spPr>
           <a:xfrm>
-            <a:off x="1399031" y="4069080"/>
+            <a:off x="1399031" y="3840480"/>
             <a:ext cx="9987991" cy="682752"/>
           </a:xfrm>
           <a:prstGeom prst="rect">
@@ -40833,7 +40843,7 @@
       </p:sp>
       <p:pic>
         <p:nvPicPr>
-          <p:cNvPr id="9" name="mermaid diagram" descr="be6527f2103f3f17.png"/>
+          <p:cNvPr id="9" name="mermaid diagram" descr="ccd9dc72bf2e93c1.png"/>
           <p:cNvPicPr>
             <a:picLocks noChangeAspect="1"/>
           </p:cNvPicPr>
@@ -40847,8 +40857,8 @@
         </p:blipFill>
         <p:spPr>
           <a:xfrm>
-            <a:off x="530352" y="1956816"/>
-            <a:ext cx="11130991" cy="1353961"/>
+            <a:off x="2602553" y="1956816"/>
+            <a:ext cx="6986587" cy="1128712"/>
           </a:xfrm>
           <a:prstGeom prst="rect">
             <a:avLst/>
@@ -40863,7 +40873,7 @@
         </p:nvSpPr>
         <p:spPr>
           <a:xfrm>
-            <a:off x="530352" y="3457081"/>
+            <a:off x="530352" y="3231832"/>
             <a:ext cx="11130991" cy="1121664"/>
           </a:xfrm>
           <a:prstGeom prst="roundRect">
@@ -40917,7 +40927,7 @@
         </p:nvSpPr>
         <p:spPr>
           <a:xfrm>
-            <a:off x="758952" y="3789313"/>
+            <a:off x="758952" y="3564064"/>
             <a:ext cx="457200" cy="457200"/>
           </a:xfrm>
           <a:prstGeom prst="ellipse">
@@ -40969,7 +40979,7 @@
         </p:blipFill>
         <p:spPr>
           <a:xfrm>
-            <a:off x="868680" y="3899041"/>
+            <a:off x="868680" y="3673792"/>
             <a:ext cx="237744" cy="237744"/>
           </a:xfrm>
           <a:prstGeom prst="rect">
@@ -40985,7 +40995,7 @@
         </p:nvSpPr>
         <p:spPr>
           <a:xfrm>
-            <a:off x="1399031" y="3603385"/>
+            <a:off x="1399031" y="3378136"/>
             <a:ext cx="9987991" cy="160401"/>
           </a:xfrm>
           <a:prstGeom prst="rect">
@@ -41020,7 +41030,7 @@
         </p:nvSpPr>
         <p:spPr>
           <a:xfrm>
-            <a:off x="1399031" y="3822841"/>
+            <a:off x="1399031" y="3597592"/>
             <a:ext cx="9987991" cy="682752"/>
           </a:xfrm>
           <a:prstGeom prst="rect">
@@ -44384,7 +44394,7 @@
       </p:sp>
       <p:pic>
         <p:nvPicPr>
-          <p:cNvPr id="10" name="mermaid diagram" descr="85555365be3c0ceb.png"/>
+          <p:cNvPr id="10" name="mermaid diagram" descr="0f2dd2aeb89fba87.png"/>
           <p:cNvPicPr>
             <a:picLocks noChangeAspect="1"/>
           </p:cNvPicPr>
@@ -44398,8 +44408,8 @@
         </p:blipFill>
         <p:spPr>
           <a:xfrm>
-            <a:off x="780897" y="1956816"/>
-            <a:ext cx="10629900" cy="2543175"/>
+            <a:off x="2638272" y="1956816"/>
+            <a:ext cx="6915150" cy="1800225"/>
           </a:xfrm>
           <a:prstGeom prst="rect">
             <a:avLst/>
@@ -44414,7 +44424,7 @@
         </p:nvSpPr>
         <p:spPr>
           <a:xfrm>
-            <a:off x="530352" y="4646295"/>
+            <a:off x="530352" y="3903345"/>
             <a:ext cx="11130991" cy="1121664"/>
           </a:xfrm>
           <a:prstGeom prst="roundRect">
@@ -44468,7 +44478,7 @@
         </p:nvSpPr>
         <p:spPr>
           <a:xfrm>
-            <a:off x="758952" y="4978527"/>
+            <a:off x="758952" y="4235577"/>
             <a:ext cx="457200" cy="457200"/>
           </a:xfrm>
           <a:prstGeom prst="ellipse">
@@ -44520,7 +44530,7 @@
         </p:blipFill>
         <p:spPr>
           <a:xfrm>
-            <a:off x="868680" y="5088255"/>
+            <a:off x="868680" y="4345305"/>
             <a:ext cx="237744" cy="237744"/>
           </a:xfrm>
           <a:prstGeom prst="rect">
@@ -44536,7 +44546,7 @@
         </p:nvSpPr>
         <p:spPr>
           <a:xfrm>
-            <a:off x="1399031" y="4792599"/>
+            <a:off x="1399031" y="4049649"/>
             <a:ext cx="9987991" cy="160401"/>
           </a:xfrm>
           <a:prstGeom prst="rect">
@@ -44571,7 +44581,7 @@
         </p:nvSpPr>
         <p:spPr>
           <a:xfrm>
-            <a:off x="1399031" y="5012055"/>
+            <a:off x="1399031" y="4269105"/>
             <a:ext cx="9987991" cy="682752"/>
           </a:xfrm>
           <a:prstGeom prst="rect">
@@ -52095,7 +52105,7 @@
       </p:sp>
       <p:pic>
         <p:nvPicPr>
-          <p:cNvPr id="9" name="mermaid diagram" descr="2148a1327f2349c8.png"/>
+          <p:cNvPr id="9" name="mermaid diagram" descr="43249a5ad3541adb.png"/>
           <p:cNvPicPr>
             <a:picLocks noChangeAspect="1"/>
           </p:cNvPicPr>
@@ -52109,8 +52119,8 @@
         </p:blipFill>
         <p:spPr>
           <a:xfrm>
-            <a:off x="1544397" y="1664208"/>
-            <a:ext cx="9102900" cy="3462528"/>
+            <a:off x="530352" y="1956816"/>
+            <a:ext cx="11130991" cy="2530416"/>
           </a:xfrm>
           <a:prstGeom prst="rect">
             <a:avLst/>
@@ -52125,7 +52135,7 @@
         </p:nvSpPr>
         <p:spPr>
           <a:xfrm>
-            <a:off x="530352" y="5172456"/>
+            <a:off x="530352" y="4633536"/>
             <a:ext cx="11130991" cy="862584"/>
           </a:xfrm>
           <a:prstGeom prst="roundRect">
@@ -52179,7 +52189,7 @@
         </p:nvSpPr>
         <p:spPr>
           <a:xfrm>
-            <a:off x="758952" y="5375148"/>
+            <a:off x="758952" y="4836228"/>
             <a:ext cx="457200" cy="457200"/>
           </a:xfrm>
           <a:prstGeom prst="ellipse">
@@ -52231,7 +52241,7 @@
         </p:blipFill>
         <p:spPr>
           <a:xfrm>
-            <a:off x="868680" y="5484876"/>
+            <a:off x="868680" y="4945956"/>
             <a:ext cx="237744" cy="237744"/>
           </a:xfrm>
           <a:prstGeom prst="rect">
@@ -52247,7 +52257,7 @@
         </p:nvSpPr>
         <p:spPr>
           <a:xfrm>
-            <a:off x="1399031" y="5318760"/>
+            <a:off x="1399031" y="4779840"/>
             <a:ext cx="9987991" cy="160401"/>
           </a:xfrm>
           <a:prstGeom prst="rect">
@@ -52282,7 +52292,7 @@
         </p:nvSpPr>
         <p:spPr>
           <a:xfrm>
-            <a:off x="1399031" y="5538216"/>
+            <a:off x="1399031" y="4999296"/>
             <a:ext cx="9987991" cy="423672"/>
           </a:xfrm>
           <a:prstGeom prst="rect">
@@ -56404,7 +56414,7 @@
       </p:sp>
       <p:pic>
         <p:nvPicPr>
-          <p:cNvPr id="9" name="mermaid diagram" descr="a2e9a95e8ae96427.png"/>
+          <p:cNvPr id="9" name="mermaid diagram" descr="baf6bf1b461432b2.png"/>
           <p:cNvPicPr>
             <a:picLocks noChangeAspect="1"/>
           </p:cNvPicPr>
@@ -56418,8 +56428,8 @@
         </p:blipFill>
         <p:spPr>
           <a:xfrm>
-            <a:off x="780897" y="1956816"/>
-            <a:ext cx="10629900" cy="1600200"/>
+            <a:off x="909485" y="1956816"/>
+            <a:ext cx="10372725" cy="1128712"/>
           </a:xfrm>
           <a:prstGeom prst="rect">
             <a:avLst/>
@@ -56434,7 +56444,7 @@
         </p:nvSpPr>
         <p:spPr>
           <a:xfrm>
-            <a:off x="530352" y="3703320"/>
+            <a:off x="530352" y="3231832"/>
             <a:ext cx="11130991" cy="772160"/>
           </a:xfrm>
           <a:prstGeom prst="rect">

</xml_diff>